<commit_message>
allowed load_results() and compute_stats() to work without seed_results.csv
</commit_message>
<xml_diff>
--- a/Presentation/ECE1508-G8-Final-Presentation.pptx
+++ b/Presentation/ECE1508-G8-Final-Presentation.pptx
@@ -11598,7 +11598,7 @@
                   <a:buNone/>
                 </a:pPr>
                 <a:r>
-                  <a:rPr lang="en" sz="1100" b="1">
+                  <a:rPr lang="en" sz="1100" b="1" dirty="0">
                     <a:solidFill>
                       <a:srgbClr val="FFFFFF"/>
                     </a:solidFill>
@@ -11607,9 +11607,9 @@
                     <a:cs typeface="Calibri"/>
                     <a:sym typeface="Calibri"/>
                   </a:rPr>
-                  <a:t>Temporal Model</a:t>
+                  <a:t>Temporal Encoder</a:t>
                 </a:r>
-                <a:endParaRPr sz="1100"/>
+                <a:endParaRPr sz="1100" dirty="0"/>
               </a:p>
             </p:txBody>
           </p:sp>

</xml_diff>